<commit_message>
Revision 2026 seance 1
</commit_message>
<xml_diff>
--- a/cours1.pptx
+++ b/cours1.pptx
@@ -5,13 +5,14 @@
     <p:sldMasterId id="2147483673" r:id="rId1"/>
   </p:sldMasterIdLst>
   <p:notesMasterIdLst>
-    <p:notesMasterId r:id="rId6"/>
+    <p:notesMasterId r:id="rId7"/>
   </p:notesMasterIdLst>
   <p:sldIdLst>
     <p:sldId id="262" r:id="rId2"/>
-    <p:sldId id="263" r:id="rId3"/>
-    <p:sldId id="264" r:id="rId4"/>
-    <p:sldId id="266" r:id="rId5"/>
+    <p:sldId id="267" r:id="rId3"/>
+    <p:sldId id="263" r:id="rId4"/>
+    <p:sldId id="264" r:id="rId5"/>
+    <p:sldId id="266" r:id="rId6"/>
   </p:sldIdLst>
   <p:sldSz cx="9144000" cy="6858000" type="screen4x3"/>
   <p:notesSz cx="6858000" cy="9144000"/>
@@ -200,7 +201,7 @@
           <a:p>
             <a:fld id="{F5549D3F-BB68-4DB2-ADF1-91AD81BE0C5A}" type="datetimeFigureOut">
               <a:rPr lang="fr-FR" smtClean="0"/>
-              <a:t>20/08/2026</a:t>
+              <a:t>14/09/2026</a:t>
             </a:fld>
             <a:endParaRPr lang="fr-FR"/>
           </a:p>
@@ -718,7 +719,7 @@
             </a:pPr>
             <a:fld id="{870BBE49-FCCB-4A90-A45C-67088542EE9F}" type="datetime1">
               <a:rPr lang="fr-FR" smtClean="0"/>
-              <a:t>20/08/2026</a:t>
+              <a:t>14/09/2026</a:t>
             </a:fld>
             <a:endParaRPr lang="fr-FR"/>
           </a:p>
@@ -953,7 +954,7 @@
             </a:pPr>
             <a:fld id="{B3571AEC-2BC4-4B6C-B79E-00D12817ECD9}" type="datetime1">
               <a:rPr lang="fr-FR" smtClean="0"/>
-              <a:t>20/08/2026</a:t>
+              <a:t>14/09/2026</a:t>
             </a:fld>
             <a:endParaRPr lang="fr-FR"/>
           </a:p>
@@ -1495,7 +1496,7 @@
             </a:pPr>
             <a:fld id="{046FFCB7-D57F-4C8C-BA32-2BA73F4500C6}" type="datetime1">
               <a:rPr lang="fr-FR" smtClean="0"/>
-              <a:t>20/08/2026</a:t>
+              <a:t>14/09/2026</a:t>
             </a:fld>
             <a:endParaRPr lang="fr-FR"/>
           </a:p>
@@ -1787,7 +1788,7 @@
             </a:pPr>
             <a:fld id="{CA852A4D-1BFF-498F-B63C-A36E50EC025B}" type="datetime1">
               <a:rPr lang="fr-FR" smtClean="0"/>
-              <a:t>20/08/2026</a:t>
+              <a:t>14/09/2026</a:t>
             </a:fld>
             <a:endParaRPr lang="fr-FR"/>
           </a:p>
@@ -2539,7 +2540,7 @@
           <p:cNvPr id="2" name="Titre 1">
             <a:extLst>
               <a:ext uri="{FF2B5EF4-FFF2-40B4-BE49-F238E27FC236}">
-                <a16:creationId xmlns:a16="http://schemas.microsoft.com/office/drawing/2014/main" id="{D030E692-33AA-4788-B51E-F185C395F5D0}"/>
+                <a16:creationId xmlns:a16="http://schemas.microsoft.com/office/drawing/2014/main" id="{5DA7A6F4-6CC8-C191-6F82-8DF42883A677}"/>
               </a:ext>
             </a:extLst>
           </p:cNvPr>
@@ -2557,13 +2558,8 @@
           <a:p>
             <a:r>
               <a:rPr lang="fr-FR" dirty="0"/>
-              <a:t>Fichier </a:t>
-            </a:r>
-            <a:r>
-              <a:rPr lang="fr-FR" dirty="0" err="1"/>
-              <a:t>json</a:t>
-            </a:r>
-            <a:endParaRPr lang="fr-FR" dirty="0"/>
+              <a:t>Rappels : listes et dictionnaire</a:t>
+            </a:r>
           </a:p>
         </p:txBody>
       </p:sp>
@@ -2572,7 +2568,7 @@
           <p:cNvPr id="3" name="Espace réservé du numéro de diapositive 2">
             <a:extLst>
               <a:ext uri="{FF2B5EF4-FFF2-40B4-BE49-F238E27FC236}">
-                <a16:creationId xmlns:a16="http://schemas.microsoft.com/office/drawing/2014/main" id="{63DE8620-766C-47C5-9F4F-4DA99E7BCCE9}"/>
+                <a16:creationId xmlns:a16="http://schemas.microsoft.com/office/drawing/2014/main" id="{B7F98D0A-8E8E-CC5B-28A9-ECBE7E21A27A}"/>
               </a:ext>
             </a:extLst>
           </p:cNvPr>
@@ -2607,7 +2603,7 @@
           <p:cNvPr id="4" name="Espace réservé du contenu 3">
             <a:extLst>
               <a:ext uri="{FF2B5EF4-FFF2-40B4-BE49-F238E27FC236}">
-                <a16:creationId xmlns:a16="http://schemas.microsoft.com/office/drawing/2014/main" id="{5377707E-8E58-46EA-BB9D-38DFC7878716}"/>
+                <a16:creationId xmlns:a16="http://schemas.microsoft.com/office/drawing/2014/main" id="{FC6EFE96-0930-1BBB-C049-276EB0AD90EA}"/>
               </a:ext>
             </a:extLst>
           </p:cNvPr>
@@ -2625,40 +2621,117 @@
           <a:p>
             <a:r>
               <a:rPr lang="fr-FR" dirty="0"/>
-              <a:t>JSON : JavaScript Object Notation</a:t>
-            </a:r>
-          </a:p>
-          <a:p>
-            <a:endParaRPr lang="fr-FR" dirty="0"/>
-          </a:p>
-          <a:p>
-            <a:r>
-              <a:rPr lang="fr-FR" dirty="0"/>
-              <a:t>Similaire à des listes et dictionnaires imbriqués</a:t>
-            </a:r>
-          </a:p>
-          <a:p>
-            <a:endParaRPr lang="fr-FR" dirty="0"/>
-          </a:p>
-          <a:p>
-            <a:r>
-              <a:rPr lang="fr-FR" dirty="0"/>
-              <a:t>Exemple : </a:t>
+              <a:t>Donner le type des objets suivants</a:t>
             </a:r>
           </a:p>
           <a:p>
             <a:pPr lvl="1"/>
             <a:r>
-              <a:rPr lang="en-US" dirty="0"/>
+              <a:rPr lang="fr-FR" sz="2000" dirty="0">
+                <a:latin typeface="Cascadia Code Light" panose="020B0609020000020004" pitchFamily="49" charset="0"/>
+                <a:ea typeface="Cascadia Code Light" panose="020B0609020000020004" pitchFamily="49" charset="0"/>
+                <a:cs typeface="Cascadia Code Light" panose="020B0609020000020004" pitchFamily="49" charset="0"/>
+              </a:rPr>
+              <a:t>["</a:t>
+            </a:r>
+            <a:r>
+              <a:rPr lang="fr-FR" sz="2000" dirty="0" err="1">
+                <a:latin typeface="Cascadia Code Light" panose="020B0609020000020004" pitchFamily="49" charset="0"/>
+                <a:ea typeface="Cascadia Code Light" panose="020B0609020000020004" pitchFamily="49" charset="0"/>
+                <a:cs typeface="Cascadia Code Light" panose="020B0609020000020004" pitchFamily="49" charset="0"/>
+              </a:rPr>
+              <a:t>Sophie","Pierre","Marc","Laurent","Isabelle</a:t>
+            </a:r>
+            <a:r>
+              <a:rPr lang="fr-FR" sz="2000" dirty="0">
+                <a:latin typeface="Cascadia Code Light" panose="020B0609020000020004" pitchFamily="49" charset="0"/>
+                <a:ea typeface="Cascadia Code Light" panose="020B0609020000020004" pitchFamily="49" charset="0"/>
+                <a:cs typeface="Cascadia Code Light" panose="020B0609020000020004" pitchFamily="49" charset="0"/>
+              </a:rPr>
+              <a:t>"]</a:t>
+            </a:r>
+          </a:p>
+          <a:p>
+            <a:pPr lvl="1"/>
+            <a:endParaRPr lang="fr-FR" sz="2000" dirty="0">
+              <a:latin typeface="Cascadia Code Light" panose="020B0609020000020004" pitchFamily="49" charset="0"/>
+              <a:ea typeface="Cascadia Code Light" panose="020B0609020000020004" pitchFamily="49" charset="0"/>
+              <a:cs typeface="Cascadia Code Light" panose="020B0609020000020004" pitchFamily="49" charset="0"/>
+            </a:endParaRPr>
+          </a:p>
+          <a:p>
+            <a:pPr lvl="1"/>
+            <a:r>
+              <a:rPr lang="fr-FR" sz="2000" dirty="0">
+                <a:latin typeface="Cascadia Code Light" panose="020B0609020000020004" pitchFamily="49" charset="0"/>
+                <a:ea typeface="Cascadia Code Light" panose="020B0609020000020004" pitchFamily="49" charset="0"/>
+                <a:cs typeface="Cascadia Code Light" panose="020B0609020000020004" pitchFamily="49" charset="0"/>
+              </a:rPr>
+              <a:t>{"Sophie":25,"Pierre":35,"Marc":22,"Laurent":114,"Isabelle":77}</a:t>
+            </a:r>
+          </a:p>
+          <a:p>
+            <a:pPr lvl="1"/>
+            <a:endParaRPr lang="fr-FR" sz="2000" dirty="0">
+              <a:latin typeface="Cascadia Code Light" panose="020B0609020000020004" pitchFamily="49" charset="0"/>
+              <a:ea typeface="Cascadia Code Light" panose="020B0609020000020004" pitchFamily="49" charset="0"/>
+              <a:cs typeface="Cascadia Code Light" panose="020B0609020000020004" pitchFamily="49" charset="0"/>
+            </a:endParaRPr>
+          </a:p>
+          <a:p>
+            <a:pPr lvl="1"/>
+            <a:r>
+              <a:rPr lang="en-US" sz="2000" dirty="0">
+                <a:latin typeface="Cascadia Code Light" panose="020B0609020000020004" pitchFamily="49" charset="0"/>
+                <a:ea typeface="Cascadia Code Light" panose="020B0609020000020004" pitchFamily="49" charset="0"/>
+                <a:cs typeface="Cascadia Code Light" panose="020B0609020000020004" pitchFamily="49" charset="0"/>
+              </a:rPr>
               <a:t>[{"name": "Michel", "height": 185},</a:t>
             </a:r>
             <a:br>
-              <a:rPr lang="en-US" dirty="0"/>
+              <a:rPr lang="en-US" sz="2000" dirty="0">
+                <a:latin typeface="Cascadia Code Light" panose="020B0609020000020004" pitchFamily="49" charset="0"/>
+                <a:ea typeface="Cascadia Code Light" panose="020B0609020000020004" pitchFamily="49" charset="0"/>
+                <a:cs typeface="Cascadia Code Light" panose="020B0609020000020004" pitchFamily="49" charset="0"/>
+              </a:rPr>
             </a:br>
             <a:r>
-              <a:rPr lang="en-US" dirty="0"/>
+              <a:rPr lang="en-US" sz="2000" dirty="0">
+                <a:latin typeface="Cascadia Code Light" panose="020B0609020000020004" pitchFamily="49" charset="0"/>
+                <a:ea typeface="Cascadia Code Light" panose="020B0609020000020004" pitchFamily="49" charset="0"/>
+                <a:cs typeface="Cascadia Code Light" panose="020B0609020000020004" pitchFamily="49" charset="0"/>
+              </a:rPr>
               <a:t>{"name": “Jean-Pierre", "height": 173, "age": 23}]</a:t>
             </a:r>
+          </a:p>
+          <a:p>
+            <a:pPr lvl="1"/>
+            <a:endParaRPr lang="en-US" sz="2000" dirty="0">
+              <a:latin typeface="Cascadia Code Light" panose="020B0609020000020004" pitchFamily="49" charset="0"/>
+              <a:ea typeface="Cascadia Code Light" panose="020B0609020000020004" pitchFamily="49" charset="0"/>
+              <a:cs typeface="Cascadia Code Light" panose="020B0609020000020004" pitchFamily="49" charset="0"/>
+            </a:endParaRPr>
+          </a:p>
+          <a:p>
+            <a:pPr lvl="1"/>
+            <a:r>
+              <a:rPr lang="fr-FR" sz="2000" dirty="0">
+                <a:latin typeface="Cascadia Code Light" panose="020B0609020000020004" pitchFamily="49" charset="0"/>
+                <a:ea typeface="Cascadia Code Light" panose="020B0609020000020004" pitchFamily="49" charset="0"/>
+                <a:cs typeface="Cascadia Code Light" panose="020B0609020000020004" pitchFamily="49" charset="0"/>
+              </a:rPr>
+              <a:t>{1:[2,3,4], 2:[12,12,12], 3:[18,12,13], 4:[3,6,18]}</a:t>
+            </a:r>
+          </a:p>
+          <a:p>
+            <a:pPr lvl="1"/>
+            <a:endParaRPr lang="fr-FR" sz="2000" dirty="0">
+              <a:latin typeface="Cascadia Code Light" panose="020B0609020000020004" pitchFamily="49" charset="0"/>
+              <a:ea typeface="Cascadia Code Light" panose="020B0609020000020004" pitchFamily="49" charset="0"/>
+              <a:cs typeface="Cascadia Code Light" panose="020B0609020000020004" pitchFamily="49" charset="0"/>
+            </a:endParaRPr>
+          </a:p>
+          <a:p>
             <a:endParaRPr lang="fr-FR" dirty="0"/>
           </a:p>
         </p:txBody>
@@ -2666,7 +2739,7 @@
     </p:spTree>
     <p:extLst>
       <p:ext uri="{BB962C8B-B14F-4D97-AF65-F5344CB8AC3E}">
-        <p14:creationId xmlns:p14="http://schemas.microsoft.com/office/powerpoint/2010/main" val="1346663170"/>
+        <p14:creationId xmlns:p14="http://schemas.microsoft.com/office/powerpoint/2010/main" val="1470743227"/>
       </p:ext>
     </p:extLst>
   </p:cSld>
@@ -2698,7 +2771,7 @@
           <p:cNvPr id="2" name="Titre 1">
             <a:extLst>
               <a:ext uri="{FF2B5EF4-FFF2-40B4-BE49-F238E27FC236}">
-                <a16:creationId xmlns:a16="http://schemas.microsoft.com/office/drawing/2014/main" id="{5509C182-832D-405E-B0A5-5DE84940DDDE}"/>
+                <a16:creationId xmlns:a16="http://schemas.microsoft.com/office/drawing/2014/main" id="{D030E692-33AA-4788-B51E-F185C395F5D0}"/>
               </a:ext>
             </a:extLst>
           </p:cNvPr>
@@ -2716,16 +2789,13 @@
           <a:p>
             <a:r>
               <a:rPr lang="fr-FR" dirty="0"/>
-              <a:t>Lire du </a:t>
+              <a:t>Fichier </a:t>
             </a:r>
             <a:r>
               <a:rPr lang="fr-FR" dirty="0" err="1"/>
               <a:t>json</a:t>
             </a:r>
-            <a:r>
-              <a:rPr lang="fr-FR" dirty="0"/>
-              <a:t> en python</a:t>
-            </a:r>
+            <a:endParaRPr lang="fr-FR" dirty="0"/>
           </a:p>
         </p:txBody>
       </p:sp>
@@ -2734,7 +2804,7 @@
           <p:cNvPr id="3" name="Espace réservé du numéro de diapositive 2">
             <a:extLst>
               <a:ext uri="{FF2B5EF4-FFF2-40B4-BE49-F238E27FC236}">
-                <a16:creationId xmlns:a16="http://schemas.microsoft.com/office/drawing/2014/main" id="{D4D446E5-660B-420A-A462-05A0E47613E0}"/>
+                <a16:creationId xmlns:a16="http://schemas.microsoft.com/office/drawing/2014/main" id="{63DE8620-766C-47C5-9F4F-4DA99E7BCCE9}"/>
               </a:ext>
             </a:extLst>
           </p:cNvPr>
@@ -2769,7 +2839,7 @@
           <p:cNvPr id="4" name="Espace réservé du contenu 3">
             <a:extLst>
               <a:ext uri="{FF2B5EF4-FFF2-40B4-BE49-F238E27FC236}">
-                <a16:creationId xmlns:a16="http://schemas.microsoft.com/office/drawing/2014/main" id="{CC0B3D8D-3563-458C-BFFD-7D3CC01C7D80}"/>
+                <a16:creationId xmlns:a16="http://schemas.microsoft.com/office/drawing/2014/main" id="{5377707E-8E58-46EA-BB9D-38DFC7878716}"/>
               </a:ext>
             </a:extLst>
           </p:cNvPr>
@@ -2787,90 +2857,48 @@
           <a:p>
             <a:r>
               <a:rPr lang="fr-FR" dirty="0"/>
-              <a:t>Importer le module </a:t>
-            </a:r>
-            <a:r>
-              <a:rPr lang="fr-FR" dirty="0" err="1"/>
-              <a:t>json</a:t>
-            </a:r>
+              <a:t>JSON : JavaScript Object Notation</a:t>
+            </a:r>
+          </a:p>
+          <a:p>
             <a:endParaRPr lang="fr-FR" dirty="0"/>
           </a:p>
           <a:p>
-            <a:pPr marL="381600" lvl="1" indent="0">
-              <a:buNone/>
-            </a:pPr>
             <a:r>
               <a:rPr lang="fr-FR" dirty="0"/>
-              <a:t>import </a:t>
-            </a:r>
-            <a:r>
-              <a:rPr lang="fr-FR" dirty="0" err="1"/>
-              <a:t>json</a:t>
-            </a:r>
+              <a:t>Similaire à des listes et dictionnaires imbriqués</a:t>
+            </a:r>
+          </a:p>
+          <a:p>
             <a:endParaRPr lang="fr-FR" dirty="0"/>
           </a:p>
           <a:p>
+            <a:r>
+              <a:rPr lang="fr-FR" dirty="0"/>
+              <a:t>Exemple : </a:t>
+            </a:r>
+          </a:p>
+          <a:p>
             <a:pPr lvl="1"/>
+            <a:r>
+              <a:rPr lang="en-US" dirty="0"/>
+              <a:t>[{"name": "Michel", "height": 185},</a:t>
+            </a:r>
+            <a:br>
+              <a:rPr lang="en-US" dirty="0"/>
+            </a:br>
+            <a:r>
+              <a:rPr lang="en-US" dirty="0"/>
+              <a:t>{"name": “Jean-Pierre", "height": 173, "age": 23}]</a:t>
+            </a:r>
             <a:endParaRPr lang="fr-FR" dirty="0"/>
-          </a:p>
-          <a:p>
-            <a:r>
-              <a:rPr lang="fr-FR" dirty="0"/>
-              <a:t>Lire le contenu d’un fichier</a:t>
-            </a:r>
-          </a:p>
-          <a:p>
-            <a:pPr marL="381600" lvl="1" indent="0">
-              <a:buNone/>
-            </a:pPr>
-            <a:r>
-              <a:rPr lang="fr-FR" dirty="0" err="1"/>
-              <a:t>fp</a:t>
-            </a:r>
-            <a:r>
-              <a:rPr lang="fr-FR" dirty="0"/>
-              <a:t> = open(" </a:t>
-            </a:r>
-            <a:r>
-              <a:rPr lang="fr-FR" dirty="0" err="1"/>
-              <a:t>monfichier.json</a:t>
-            </a:r>
-            <a:r>
-              <a:rPr lang="fr-FR" dirty="0"/>
-              <a:t> "  , " r")</a:t>
-            </a:r>
-          </a:p>
-          <a:p>
-            <a:pPr marL="381600" lvl="1" indent="0">
-              <a:buNone/>
-            </a:pPr>
-            <a:r>
-              <a:rPr lang="fr-FR" dirty="0"/>
-              <a:t>contenu = </a:t>
-            </a:r>
-            <a:r>
-              <a:rPr lang="fr-FR" dirty="0" err="1"/>
-              <a:t>json.load</a:t>
-            </a:r>
-            <a:r>
-              <a:rPr lang="fr-FR" dirty="0"/>
-              <a:t>(</a:t>
-            </a:r>
-            <a:r>
-              <a:rPr lang="fr-FR" dirty="0" err="1"/>
-              <a:t>fp</a:t>
-            </a:r>
-            <a:r>
-              <a:rPr lang="fr-FR" dirty="0"/>
-              <a:t>)</a:t>
-            </a:r>
           </a:p>
         </p:txBody>
       </p:sp>
     </p:spTree>
     <p:extLst>
       <p:ext uri="{BB962C8B-B14F-4D97-AF65-F5344CB8AC3E}">
-        <p14:creationId xmlns:p14="http://schemas.microsoft.com/office/powerpoint/2010/main" val="2310590688"/>
+        <p14:creationId xmlns:p14="http://schemas.microsoft.com/office/powerpoint/2010/main" val="1346663170"/>
       </p:ext>
     </p:extLst>
   </p:cSld>
@@ -2919,12 +2947,8 @@
           <a:lstStyle/>
           <a:p>
             <a:r>
-              <a:rPr lang="fr-FR" dirty="0" err="1"/>
-              <a:t>ecrire</a:t>
-            </a:r>
-            <a:r>
               <a:rPr lang="fr-FR" dirty="0"/>
-              <a:t> du </a:t>
+              <a:t>Lire du </a:t>
             </a:r>
             <a:r>
               <a:rPr lang="fr-FR" dirty="0" err="1"/>
@@ -3024,7 +3048,7 @@
           <a:p>
             <a:r>
               <a:rPr lang="fr-FR" dirty="0"/>
-              <a:t>Ecrire un contenu (dictionnaire, une liste de dictionnaires …) dans un fichier</a:t>
+              <a:t>Lire le contenu d’un fichier</a:t>
             </a:r>
           </a:p>
           <a:p>
@@ -3033,11 +3057,11 @@
             </a:pPr>
             <a:r>
               <a:rPr lang="fr-FR" dirty="0" err="1"/>
-              <a:t>fp</a:t>
+              <a:t>with</a:t>
             </a:r>
             <a:r>
               <a:rPr lang="fr-FR" dirty="0"/>
-              <a:t> = open(" </a:t>
+              <a:t> open(" </a:t>
             </a:r>
             <a:r>
               <a:rPr lang="fr-FR" dirty="0" err="1"/>
@@ -3045,13 +3069,241 @@
             </a:r>
             <a:r>
               <a:rPr lang="fr-FR" dirty="0"/>
-              <a:t> "  , " w")</a:t>
+              <a:t> "  , " r") as </a:t>
+            </a:r>
+            <a:r>
+              <a:rPr lang="fr-FR" dirty="0" err="1"/>
+              <a:t>fp</a:t>
+            </a:r>
+            <a:r>
+              <a:rPr lang="fr-FR" dirty="0"/>
+              <a:t> : </a:t>
             </a:r>
           </a:p>
           <a:p>
             <a:pPr marL="381600" lvl="1" indent="0">
               <a:buNone/>
             </a:pPr>
+            <a:r>
+              <a:rPr lang="fr-FR" dirty="0"/>
+              <a:t>		contenu = </a:t>
+            </a:r>
+            <a:r>
+              <a:rPr lang="fr-FR" dirty="0" err="1"/>
+              <a:t>json.load</a:t>
+            </a:r>
+            <a:r>
+              <a:rPr lang="fr-FR" dirty="0"/>
+              <a:t>(</a:t>
+            </a:r>
+            <a:r>
+              <a:rPr lang="fr-FR" dirty="0" err="1"/>
+              <a:t>fp</a:t>
+            </a:r>
+            <a:r>
+              <a:rPr lang="fr-FR" dirty="0"/>
+              <a:t>)</a:t>
+            </a:r>
+          </a:p>
+        </p:txBody>
+      </p:sp>
+    </p:spTree>
+    <p:extLst>
+      <p:ext uri="{BB962C8B-B14F-4D97-AF65-F5344CB8AC3E}">
+        <p14:creationId xmlns:p14="http://schemas.microsoft.com/office/powerpoint/2010/main" val="2310590688"/>
+      </p:ext>
+    </p:extLst>
+  </p:cSld>
+  <p:clrMapOvr>
+    <a:masterClrMapping/>
+  </p:clrMapOvr>
+</p:sld>
+</file>
+
+<file path=ppt/slides/slide5.xml><?xml version="1.0" encoding="utf-8"?>
+<p:sld xmlns:a="http://schemas.openxmlformats.org/drawingml/2006/main" xmlns:r="http://schemas.openxmlformats.org/officeDocument/2006/relationships" xmlns:p="http://schemas.openxmlformats.org/presentationml/2006/main">
+  <p:cSld>
+    <p:spTree>
+      <p:nvGrpSpPr>
+        <p:cNvPr id="1" name=""/>
+        <p:cNvGrpSpPr/>
+        <p:nvPr/>
+      </p:nvGrpSpPr>
+      <p:grpSpPr>
+        <a:xfrm>
+          <a:off x="0" y="0"/>
+          <a:ext cx="0" cy="0"/>
+          <a:chOff x="0" y="0"/>
+          <a:chExt cx="0" cy="0"/>
+        </a:xfrm>
+      </p:grpSpPr>
+      <p:sp>
+        <p:nvSpPr>
+          <p:cNvPr id="2" name="Titre 1">
+            <a:extLst>
+              <a:ext uri="{FF2B5EF4-FFF2-40B4-BE49-F238E27FC236}">
+                <a16:creationId xmlns:a16="http://schemas.microsoft.com/office/drawing/2014/main" id="{5509C182-832D-405E-B0A5-5DE84940DDDE}"/>
+              </a:ext>
+            </a:extLst>
+          </p:cNvPr>
+          <p:cNvSpPr>
+            <a:spLocks noGrp="1"/>
+          </p:cNvSpPr>
+          <p:nvPr>
+            <p:ph type="title"/>
+          </p:nvPr>
+        </p:nvSpPr>
+        <p:spPr/>
+        <p:txBody>
+          <a:bodyPr/>
+          <a:lstStyle/>
+          <a:p>
+            <a:r>
+              <a:rPr lang="fr-FR" dirty="0" err="1"/>
+              <a:t>ecrire</a:t>
+            </a:r>
+            <a:r>
+              <a:rPr lang="fr-FR" dirty="0"/>
+              <a:t> du </a:t>
+            </a:r>
+            <a:r>
+              <a:rPr lang="fr-FR" dirty="0" err="1"/>
+              <a:t>json</a:t>
+            </a:r>
+            <a:r>
+              <a:rPr lang="fr-FR" dirty="0"/>
+              <a:t> en python</a:t>
+            </a:r>
+          </a:p>
+        </p:txBody>
+      </p:sp>
+      <p:sp>
+        <p:nvSpPr>
+          <p:cNvPr id="3" name="Espace réservé du numéro de diapositive 2">
+            <a:extLst>
+              <a:ext uri="{FF2B5EF4-FFF2-40B4-BE49-F238E27FC236}">
+                <a16:creationId xmlns:a16="http://schemas.microsoft.com/office/drawing/2014/main" id="{D4D446E5-660B-420A-A462-05A0E47613E0}"/>
+              </a:ext>
+            </a:extLst>
+          </p:cNvPr>
+          <p:cNvSpPr>
+            <a:spLocks noGrp="1"/>
+          </p:cNvSpPr>
+          <p:nvPr>
+            <p:ph type="sldNum" sz="quarter" idx="12"/>
+          </p:nvPr>
+        </p:nvSpPr>
+        <p:spPr/>
+        <p:txBody>
+          <a:bodyPr/>
+          <a:lstStyle/>
+          <a:p>
+            <a:pPr>
+              <a:defRPr/>
+            </a:pPr>
+            <a:fld id="{D727A26F-F00B-4596-8258-FF21EF8271F6}" type="slidenum">
+              <a:rPr lang="fr-FR" smtClean="0"/>
+              <a:pPr>
+                <a:defRPr/>
+              </a:pPr>
+              <a:t>5</a:t>
+            </a:fld>
+            <a:endParaRPr lang="fr-FR" dirty="0"/>
+          </a:p>
+        </p:txBody>
+      </p:sp>
+      <p:sp>
+        <p:nvSpPr>
+          <p:cNvPr id="4" name="Espace réservé du contenu 3">
+            <a:extLst>
+              <a:ext uri="{FF2B5EF4-FFF2-40B4-BE49-F238E27FC236}">
+                <a16:creationId xmlns:a16="http://schemas.microsoft.com/office/drawing/2014/main" id="{CC0B3D8D-3563-458C-BFFD-7D3CC01C7D80}"/>
+              </a:ext>
+            </a:extLst>
+          </p:cNvPr>
+          <p:cNvSpPr>
+            <a:spLocks noGrp="1"/>
+          </p:cNvSpPr>
+          <p:nvPr>
+            <p:ph idx="1"/>
+          </p:nvPr>
+        </p:nvSpPr>
+        <p:spPr/>
+        <p:txBody>
+          <a:bodyPr/>
+          <a:lstStyle/>
+          <a:p>
+            <a:r>
+              <a:rPr lang="fr-FR" dirty="0"/>
+              <a:t>Importer le module </a:t>
+            </a:r>
+            <a:r>
+              <a:rPr lang="fr-FR" dirty="0" err="1"/>
+              <a:t>json</a:t>
+            </a:r>
+            <a:endParaRPr lang="fr-FR" dirty="0"/>
+          </a:p>
+          <a:p>
+            <a:pPr marL="381600" lvl="1" indent="0">
+              <a:buNone/>
+            </a:pPr>
+            <a:r>
+              <a:rPr lang="fr-FR" dirty="0"/>
+              <a:t>import </a:t>
+            </a:r>
+            <a:r>
+              <a:rPr lang="fr-FR" dirty="0" err="1"/>
+              <a:t>json</a:t>
+            </a:r>
+            <a:endParaRPr lang="fr-FR" dirty="0"/>
+          </a:p>
+          <a:p>
+            <a:pPr lvl="1"/>
+            <a:endParaRPr lang="fr-FR" dirty="0"/>
+          </a:p>
+          <a:p>
+            <a:r>
+              <a:rPr lang="fr-FR" dirty="0"/>
+              <a:t>Ecrire un contenu (dictionnaire, une liste de dictionnaires …) dans un fichier</a:t>
+            </a:r>
+          </a:p>
+          <a:p>
+            <a:pPr marL="381600" lvl="1" indent="0">
+              <a:buNone/>
+            </a:pPr>
+            <a:r>
+              <a:rPr lang="fr-FR" dirty="0" err="1"/>
+              <a:t>with</a:t>
+            </a:r>
+            <a:r>
+              <a:rPr lang="fr-FR" dirty="0"/>
+              <a:t> open(" </a:t>
+            </a:r>
+            <a:r>
+              <a:rPr lang="fr-FR" dirty="0" err="1"/>
+              <a:t>monfichier.json</a:t>
+            </a:r>
+            <a:r>
+              <a:rPr lang="fr-FR" dirty="0"/>
+              <a:t> "  , " w") as </a:t>
+            </a:r>
+            <a:r>
+              <a:rPr lang="fr-FR" dirty="0" err="1"/>
+              <a:t>fp</a:t>
+            </a:r>
+            <a:r>
+              <a:rPr lang="fr-FR" dirty="0"/>
+              <a:t> : </a:t>
+            </a:r>
+          </a:p>
+          <a:p>
+            <a:pPr marL="381600" lvl="1" indent="0">
+              <a:buNone/>
+            </a:pPr>
+            <a:r>
+              <a:rPr lang="fr-FR" dirty="0"/>
+              <a:t>			</a:t>
+            </a:r>
             <a:r>
               <a:rPr lang="fr-FR" dirty="0" err="1"/>
               <a:t>json.dump</a:t>

</xml_diff>